<commit_message>
Clean up docs, metadata and comments
</commit_message>
<xml_diff>
--- a/docs/GlucoTwin_Deck.pptx
+++ b/docs/GlucoTwin_Deck.pptx
@@ -1918,7 +1918,7 @@
       </p:sp>
       <p:pic>
         <p:nvPicPr>
-          <p:cNvPr id="5" name="Image 0" descr="/home/claude/GlucoTwin/docs/img/icons/heartbeat_#ffffff.png">    </p:cNvPr>
+          <p:cNvPr id="5" name="Image 0" descr="heartbeat icon">    </p:cNvPr>
           <p:cNvPicPr>
             <a:picLocks noChangeAspect="1"/>
           </p:cNvPicPr>
@@ -2597,7 +2597,7 @@
       </p:sp>
       <p:pic>
         <p:nvPicPr>
-          <p:cNvPr id="6" name="Image 0" descr="/home/claude/GlucoTwin/docs/img/icons/walking_#ffffff.png">    </p:cNvPr>
+          <p:cNvPr id="6" name="Image 0" descr="walking icon">    </p:cNvPr>
           <p:cNvPicPr>
             <a:picLocks noChangeAspect="1"/>
           </p:cNvPicPr>
@@ -2773,7 +2773,7 @@
       </p:sp>
       <p:pic>
         <p:nvPicPr>
-          <p:cNvPr id="11" name="Image 1" descr="/home/claude/GlucoTwin/docs/img/icons/moon_#ffffff.png">    </p:cNvPr>
+          <p:cNvPr id="11" name="Image 1" descr="moon icon">    </p:cNvPr>
           <p:cNvPicPr>
             <a:picLocks noChangeAspect="1"/>
           </p:cNvPicPr>
@@ -2949,7 +2949,7 @@
       </p:sp>
       <p:pic>
         <p:nvPicPr>
-          <p:cNvPr id="16" name="Image 2" descr="/home/claude/GlucoTwin/docs/img/icons/pills_#ffffff.png">    </p:cNvPr>
+          <p:cNvPr id="16" name="Image 2" descr="pills icon">    </p:cNvPr>
           <p:cNvPicPr>
             <a:picLocks noChangeAspect="1"/>
           </p:cNvPicPr>
@@ -3102,7 +3102,7 @@
       </p:sp>
       <p:pic>
         <p:nvPicPr>
-          <p:cNvPr id="20" name="Image 3" descr="/home/claude/GlucoTwin/docs/img/icons/apple_#ffffff.png">    </p:cNvPr>
+          <p:cNvPr id="20" name="Image 3" descr="apple icon">    </p:cNvPr>
           <p:cNvPicPr>
             <a:picLocks noChangeAspect="1"/>
           </p:cNvPicPr>
@@ -3544,7 +3544,7 @@
       </p:sp>
       <p:pic>
         <p:nvPicPr>
-          <p:cNvPr id="6" name="Image 0" descr="/home/claude/GlucoTwin/docs/img/icons/hospital_#ffffff.png">    </p:cNvPr>
+          <p:cNvPr id="6" name="Image 0" descr="hospital icon">    </p:cNvPr>
           <p:cNvPicPr>
             <a:picLocks noChangeAspect="1"/>
           </p:cNvPicPr>
@@ -3669,7 +3669,7 @@
       </p:sp>
       <p:pic>
         <p:nvPicPr>
-          <p:cNvPr id="10" name="Image 1" descr="/home/claude/GlucoTwin/docs/img/icons/target_#ffffff.png">    </p:cNvPr>
+          <p:cNvPr id="10" name="Image 1" descr="target icon">    </p:cNvPr>
           <p:cNvPicPr>
             <a:picLocks noChangeAspect="1"/>
           </p:cNvPicPr>
@@ -3794,7 +3794,7 @@
       </p:sp>
       <p:pic>
         <p:nvPicPr>
-          <p:cNvPr id="14" name="Image 2" descr="/home/claude/GlucoTwin/docs/img/icons/heartbeat_#ffffff.png">    </p:cNvPr>
+          <p:cNvPr id="14" name="Image 2" descr="heartbeat icon">    </p:cNvPr>
           <p:cNvPicPr>
             <a:picLocks noChangeAspect="1"/>
           </p:cNvPicPr>
@@ -3919,7 +3919,7 @@
       </p:sp>
       <p:pic>
         <p:nvPicPr>
-          <p:cNvPr id="18" name="Image 3" descr="/home/claude/GlucoTwin/docs/img/icons/globe_#ffffff.png">    </p:cNvPr>
+          <p:cNvPr id="18" name="Image 3" descr="globe icon">    </p:cNvPr>
           <p:cNvPicPr>
             <a:picLocks noChangeAspect="1"/>
           </p:cNvPicPr>
@@ -4862,7 +4862,7 @@
       </p:sp>
       <p:pic>
         <p:nvPicPr>
-          <p:cNvPr id="4" name="Image 0" descr="/home/claude/GlucoTwin/docs/img/icons/heart_#ffffff.png">    </p:cNvPr>
+          <p:cNvPr id="4" name="Image 0" descr="heart icon">    </p:cNvPr>
           <p:cNvPicPr>
             <a:picLocks noChangeAspect="1"/>
           </p:cNvPicPr>
@@ -7723,7 +7723,7 @@
       </p:sp>
       <p:pic>
         <p:nvPicPr>
-          <p:cNvPr id="4" name="Image 0" descr="/home/claude/GlucoTwin/docs/img/architecture.png">    </p:cNvPr>
+          <p:cNvPr id="4" name="Image 0" descr="System architecture">    </p:cNvPr>
           <p:cNvPicPr>
             <a:picLocks noChangeAspect="1"/>
           </p:cNvPicPr>
@@ -8587,7 +8587,7 @@
       </p:sp>
       <p:pic>
         <p:nvPicPr>
-          <p:cNvPr id="4" name="Image 0" descr="/home/claude/GlucoTwin/artifacts/plots/ablation.png">    </p:cNvPr>
+          <p:cNvPr id="4" name="Image 0" descr="Ablation results">    </p:cNvPr>
           <p:cNvPicPr>
             <a:picLocks noChangeAspect="1"/>
           </p:cNvPicPr>
@@ -9395,7 +9395,7 @@
       </p:sp>
       <p:pic>
         <p:nvPicPr>
-          <p:cNvPr id="4" name="Image 0" descr="/home/claude/GlucoTwin/artifacts/plots/global_importance.png">    </p:cNvPr>
+          <p:cNvPr id="4" name="Image 0" descr="Feature importance">    </p:cNvPr>
           <p:cNvPicPr>
             <a:picLocks noChangeAspect="1"/>
           </p:cNvPicPr>
@@ -9962,7 +9962,7 @@
       </p:sp>
       <p:pic>
         <p:nvPicPr>
-          <p:cNvPr id="4" name="Image 0" descr="/home/claude/GlucoTwin/docs/img/dash_hero.png">    </p:cNvPr>
+          <p:cNvPr id="4" name="Image 0" descr="GlucoTwin dashboard">    </p:cNvPr>
           <p:cNvPicPr>
             <a:picLocks noChangeAspect="1"/>
           </p:cNvPicPr>

</xml_diff>